<commit_message>
4章 pptx: 4-11・4-12・4-14 分割後の再ビルド（4-11・4-12 は fix 前、WIP 11）
Co-Authored-By: Claude Fable 5.1 <noreply@anthropic.com>
Claude-Session: https://claude.ai/code/session_01SAUkWCQGmQmBwHabYZKgkn
</commit_message>
<xml_diff>
--- a/slides/4-12_antithrombotic_drugs/4-12_antithrombotic_drugs.pptx
+++ b/slides/4-12_antithrombotic_drugs/4-12_antithrombotic_drugs.pptx
@@ -2415,7 +2415,7 @@
                 <a:ea typeface="メイリオ" pitchFamily="34" charset="-122"/>
                 <a:cs typeface="メイリオ" pitchFamily="34" charset="-120"/>
               </a:rPr>
-              <a:t>抗血小板</a:t>
+              <a:t>抗血小</a:t>
             </a:r>
             <a:endParaRPr lang="ja-JP" sz="1050" dirty="0"/>
           </a:p>
@@ -2432,7 +2432,7 @@
                 <a:ea typeface="メイリオ" pitchFamily="34" charset="-122"/>
                 <a:cs typeface="メイリオ" pitchFamily="34" charset="-120"/>
               </a:rPr>
-              <a:t>薬</a:t>
+              <a:t>板薬</a:t>
             </a:r>
             <a:endParaRPr lang="ja-JP" sz="1050" dirty="0"/>
           </a:p>
@@ -3059,7 +3059,7 @@
                 <a:ea typeface="メイリオ" pitchFamily="34" charset="-122"/>
                 <a:cs typeface="メイリオ" pitchFamily="34" charset="-120"/>
               </a:rPr>
-              <a:t>抗血小板</a:t>
+              <a:t>抗血小</a:t>
             </a:r>
             <a:endParaRPr lang="ja-JP" sz="1050" dirty="0"/>
           </a:p>
@@ -3076,7 +3076,7 @@
                 <a:ea typeface="メイリオ" pitchFamily="34" charset="-122"/>
                 <a:cs typeface="メイリオ" pitchFamily="34" charset="-120"/>
               </a:rPr>
-              <a:t>薬</a:t>
+              <a:t>板薬</a:t>
             </a:r>
             <a:endParaRPr lang="ja-JP" sz="1050" dirty="0"/>
           </a:p>
@@ -4789,7 +4789,7 @@
                 <a:ea typeface="メイリオ" pitchFamily="34" charset="-122"/>
                 <a:cs typeface="メイリオ" pitchFamily="34" charset="-120"/>
               </a:rPr>
-              <a:t>抗血小板</a:t>
+              <a:t>抗血小</a:t>
             </a:r>
             <a:endParaRPr lang="ja-JP" sz="1050" dirty="0"/>
           </a:p>
@@ -4806,7 +4806,7 @@
                 <a:ea typeface="メイリオ" pitchFamily="34" charset="-122"/>
                 <a:cs typeface="メイリオ" pitchFamily="34" charset="-120"/>
               </a:rPr>
-              <a:t>薬</a:t>
+              <a:t>板薬</a:t>
             </a:r>
             <a:endParaRPr lang="ja-JP" sz="1050" dirty="0"/>
           </a:p>
@@ -5754,7 +5754,7 @@
                 <a:ea typeface="メイリオ" pitchFamily="34" charset="-122"/>
                 <a:cs typeface="メイリオ" pitchFamily="34" charset="-120"/>
               </a:rPr>
-              <a:t>抗血小板</a:t>
+              <a:t>抗血小</a:t>
             </a:r>
             <a:endParaRPr lang="ja-JP" sz="1050" dirty="0"/>
           </a:p>
@@ -5771,7 +5771,7 @@
                 <a:ea typeface="メイリオ" pitchFamily="34" charset="-122"/>
                 <a:cs typeface="メイリオ" pitchFamily="34" charset="-120"/>
               </a:rPr>
-              <a:t>薬</a:t>
+              <a:t>板薬</a:t>
             </a:r>
             <a:endParaRPr lang="ja-JP" sz="1050" dirty="0"/>
           </a:p>
@@ -6172,7 +6172,7 @@
         <p:spPr>
           <a:xfrm>
             <a:off x="576072" y="2063801"/>
-            <a:ext cx="6249010" cy="374904"/>
+            <a:ext cx="320040" cy="374904"/>
           </a:xfrm>
           <a:prstGeom prst="rect">
             <a:avLst/>
@@ -6188,7 +6188,7 @@
               <a:buNone/>
             </a:pPr>
             <a:r>
-              <a:rPr lang="ja-JP" altLang="en-US" sz="2200" b="1" dirty="0">
+              <a:rPr lang="ja-JP" altLang="en-US" sz="2200" dirty="0">
                 <a:solidFill>
                   <a:srgbClr val="262626"/>
                 </a:solidFill>
@@ -6196,18 +6196,7 @@
                 <a:ea typeface="メイリオ" pitchFamily="34" charset="-122"/>
                 <a:cs typeface="メイリオ" pitchFamily="34" charset="-120"/>
               </a:rPr>
-              <a:t>低リスク：</a:t>
-            </a:r>
-            <a:r>
-              <a:rPr lang="ja-JP" altLang="en-US" sz="2200" dirty="0">
-                <a:solidFill>
-                  <a:srgbClr val="262626"/>
-                </a:solidFill>
-                <a:latin typeface="メイリオ" pitchFamily="34" charset="0"/>
-                <a:ea typeface="メイリオ" pitchFamily="34" charset="-122"/>
-                <a:cs typeface="メイリオ" pitchFamily="34" charset="-120"/>
-              </a:rPr>
-              <a:t>1 日休薬、翌日に再開</a:t>
+              <a:t>•</a:t>
             </a:r>
             <a:endParaRPr lang="ja-JP" sz="2200" dirty="0"/>
           </a:p>
@@ -6221,8 +6210,8 @@
         </p:nvSpPr>
         <p:spPr>
           <a:xfrm>
-            <a:off x="576072" y="2398471"/>
-            <a:ext cx="6249010" cy="374904"/>
+            <a:off x="832104" y="2063801"/>
+            <a:ext cx="5992978" cy="374904"/>
           </a:xfrm>
           <a:prstGeom prst="rect">
             <a:avLst/>
@@ -6246,7 +6235,7 @@
                 <a:ea typeface="メイリオ" pitchFamily="34" charset="-122"/>
                 <a:cs typeface="メイリオ" pitchFamily="34" charset="-120"/>
               </a:rPr>
-              <a:t>高リスク：</a:t>
+              <a:t>低リスク：</a:t>
             </a:r>
             <a:r>
               <a:rPr lang="ja-JP" altLang="en-US" sz="2200" dirty="0">
@@ -6257,7 +6246,7 @@
                 <a:ea typeface="メイリオ" pitchFamily="34" charset="-122"/>
                 <a:cs typeface="メイリオ" pitchFamily="34" charset="-120"/>
               </a:rPr>
-              <a:t>2 日休薬</a:t>
+              <a:t>1 日休薬、翌日に再開</a:t>
             </a:r>
             <a:endParaRPr lang="ja-JP" sz="2200" dirty="0"/>
           </a:p>
@@ -6271,6 +6260,95 @@
         </p:nvSpPr>
         <p:spPr>
           <a:xfrm>
+            <a:off x="576072" y="2398471"/>
+            <a:ext cx="320040" cy="374904"/>
+          </a:xfrm>
+          <a:prstGeom prst="rect">
+            <a:avLst/>
+          </a:prstGeom>
+          <a:noFill/>
+          <a:ln/>
+        </p:spPr>
+        <p:txBody>
+          <a:bodyPr wrap="square" lIns="0" tIns="0" rIns="0" bIns="0" rtlCol="0" anchor="t"/>
+          <a:lstStyle/>
+          <a:p>
+            <a:pPr algn="l" indent="0" marL="0">
+              <a:buNone/>
+            </a:pPr>
+            <a:r>
+              <a:rPr lang="ja-JP" altLang="en-US" sz="2200" dirty="0">
+                <a:solidFill>
+                  <a:srgbClr val="262626"/>
+                </a:solidFill>
+                <a:latin typeface="メイリオ" pitchFamily="34" charset="0"/>
+                <a:ea typeface="メイリオ" pitchFamily="34" charset="-122"/>
+                <a:cs typeface="メイリオ" pitchFamily="34" charset="-120"/>
+              </a:rPr>
+              <a:t>•</a:t>
+            </a:r>
+            <a:endParaRPr lang="ja-JP" sz="2200" dirty="0"/>
+          </a:p>
+        </p:txBody>
+      </p:sp>
+      <p:sp>
+        <p:nvSpPr>
+          <p:cNvPr id="19" name="Text 17"/>
+          <p:cNvSpPr txBox="1"/>
+          <p:nvPr/>
+        </p:nvSpPr>
+        <p:spPr>
+          <a:xfrm>
+            <a:off x="832104" y="2398471"/>
+            <a:ext cx="5992978" cy="374904"/>
+          </a:xfrm>
+          <a:prstGeom prst="rect">
+            <a:avLst/>
+          </a:prstGeom>
+          <a:noFill/>
+          <a:ln/>
+        </p:spPr>
+        <p:txBody>
+          <a:bodyPr wrap="square" lIns="0" tIns="0" rIns="0" bIns="0" rtlCol="0" anchor="t"/>
+          <a:lstStyle/>
+          <a:p>
+            <a:pPr algn="l" indent="0" marL="0">
+              <a:buNone/>
+            </a:pPr>
+            <a:r>
+              <a:rPr lang="ja-JP" altLang="en-US" sz="2200" b="1" dirty="0">
+                <a:solidFill>
+                  <a:srgbClr val="262626"/>
+                </a:solidFill>
+                <a:latin typeface="メイリオ" pitchFamily="34" charset="0"/>
+                <a:ea typeface="メイリオ" pitchFamily="34" charset="-122"/>
+                <a:cs typeface="メイリオ" pitchFamily="34" charset="-120"/>
+              </a:rPr>
+              <a:t>高リスク：</a:t>
+            </a:r>
+            <a:r>
+              <a:rPr lang="ja-JP" altLang="en-US" sz="2200" dirty="0">
+                <a:solidFill>
+                  <a:srgbClr val="262626"/>
+                </a:solidFill>
+                <a:latin typeface="メイリオ" pitchFamily="34" charset="0"/>
+                <a:ea typeface="メイリオ" pitchFamily="34" charset="-122"/>
+                <a:cs typeface="メイリオ" pitchFamily="34" charset="-120"/>
+              </a:rPr>
+              <a:t>2 日休薬</a:t>
+            </a:r>
+            <a:endParaRPr lang="ja-JP" sz="2200" dirty="0"/>
+          </a:p>
+        </p:txBody>
+      </p:sp>
+      <p:sp>
+        <p:nvSpPr>
+          <p:cNvPr id="20" name="Text 18"/>
+          <p:cNvSpPr txBox="1"/>
+          <p:nvPr/>
+        </p:nvSpPr>
+        <p:spPr>
+          <a:xfrm>
             <a:off x="576072" y="2734056"/>
             <a:ext cx="6249010" cy="374904"/>
           </a:xfrm>
@@ -6304,7 +6382,7 @@
       </p:sp>
       <p:sp>
         <p:nvSpPr>
-          <p:cNvPr id="19" name="Text 17"/>
+          <p:cNvPr id="21" name="Text 19"/>
           <p:cNvSpPr txBox="1"/>
           <p:nvPr/>
         </p:nvSpPr>
@@ -6343,14 +6421,14 @@
       </p:sp>
       <p:sp>
         <p:nvSpPr>
-          <p:cNvPr id="20" name="Text 18"/>
+          <p:cNvPr id="22" name="Text 20"/>
           <p:cNvSpPr txBox="1"/>
           <p:nvPr/>
         </p:nvSpPr>
         <p:spPr>
           <a:xfrm>
             <a:off x="576072" y="3404311"/>
-            <a:ext cx="6249010" cy="374904"/>
+            <a:ext cx="320040" cy="374904"/>
           </a:xfrm>
           <a:prstGeom prst="rect">
             <a:avLst/>
@@ -6366,6 +6444,45 @@
               <a:buNone/>
             </a:pPr>
             <a:r>
+              <a:rPr lang="ja-JP" altLang="en-US" sz="2200" dirty="0">
+                <a:solidFill>
+                  <a:srgbClr val="262626"/>
+                </a:solidFill>
+                <a:latin typeface="メイリオ" pitchFamily="34" charset="0"/>
+                <a:ea typeface="メイリオ" pitchFamily="34" charset="-122"/>
+                <a:cs typeface="メイリオ" pitchFamily="34" charset="-120"/>
+              </a:rPr>
+              <a:t>•</a:t>
+            </a:r>
+            <a:endParaRPr lang="ja-JP" sz="2200" dirty="0"/>
+          </a:p>
+        </p:txBody>
+      </p:sp>
+      <p:sp>
+        <p:nvSpPr>
+          <p:cNvPr id="23" name="Text 21"/>
+          <p:cNvSpPr txBox="1"/>
+          <p:nvPr/>
+        </p:nvSpPr>
+        <p:spPr>
+          <a:xfrm>
+            <a:off x="832104" y="3404311"/>
+            <a:ext cx="5992978" cy="374904"/>
+          </a:xfrm>
+          <a:prstGeom prst="rect">
+            <a:avLst/>
+          </a:prstGeom>
+          <a:noFill/>
+          <a:ln/>
+        </p:spPr>
+        <p:txBody>
+          <a:bodyPr wrap="square" lIns="0" tIns="0" rIns="0" bIns="0" rtlCol="0" anchor="t"/>
+          <a:lstStyle/>
+          <a:p>
+            <a:pPr algn="l" indent="0" marL="0">
+              <a:buNone/>
+            </a:pPr>
+            <a:r>
               <a:rPr lang="ja-JP" altLang="en-US" sz="2200" b="1" dirty="0">
                 <a:solidFill>
                   <a:srgbClr val="262626"/>
@@ -6382,7 +6499,7 @@
       </p:sp>
       <p:sp>
         <p:nvSpPr>
-          <p:cNvPr id="21" name="Text 19"/>
+          <p:cNvPr id="24" name="Text 22"/>
           <p:cNvSpPr txBox="1"/>
           <p:nvPr/>
         </p:nvSpPr>
@@ -6421,7 +6538,7 @@
       </p:sp>
       <p:sp>
         <p:nvSpPr>
-          <p:cNvPr id="22" name="Text 20"/>
+          <p:cNvPr id="25" name="Text 23"/>
           <p:cNvSpPr txBox="1"/>
           <p:nvPr/>
         </p:nvSpPr>
@@ -6460,14 +6577,14 @@
       </p:sp>
       <p:sp>
         <p:nvSpPr>
-          <p:cNvPr id="23" name="Text 21"/>
+          <p:cNvPr id="26" name="Text 24"/>
           <p:cNvSpPr txBox="1"/>
           <p:nvPr/>
         </p:nvSpPr>
         <p:spPr>
           <a:xfrm>
             <a:off x="576072" y="4410151"/>
-            <a:ext cx="6249010" cy="374904"/>
+            <a:ext cx="320040" cy="374904"/>
           </a:xfrm>
           <a:prstGeom prst="rect">
             <a:avLst/>
@@ -6483,6 +6600,45 @@
               <a:buNone/>
             </a:pPr>
             <a:r>
+              <a:rPr lang="ja-JP" altLang="en-US" sz="2200" dirty="0">
+                <a:solidFill>
+                  <a:srgbClr val="262626"/>
+                </a:solidFill>
+                <a:latin typeface="メイリオ" pitchFamily="34" charset="0"/>
+                <a:ea typeface="メイリオ" pitchFamily="34" charset="-122"/>
+                <a:cs typeface="メイリオ" pitchFamily="34" charset="-120"/>
+              </a:rPr>
+              <a:t>•</a:t>
+            </a:r>
+            <a:endParaRPr lang="ja-JP" sz="2200" dirty="0"/>
+          </a:p>
+        </p:txBody>
+      </p:sp>
+      <p:sp>
+        <p:nvSpPr>
+          <p:cNvPr id="27" name="Text 25"/>
+          <p:cNvSpPr txBox="1"/>
+          <p:nvPr/>
+        </p:nvSpPr>
+        <p:spPr>
+          <a:xfrm>
+            <a:off x="832104" y="4410151"/>
+            <a:ext cx="5992978" cy="374904"/>
+          </a:xfrm>
+          <a:prstGeom prst="rect">
+            <a:avLst/>
+          </a:prstGeom>
+          <a:noFill/>
+          <a:ln/>
+        </p:spPr>
+        <p:txBody>
+          <a:bodyPr wrap="square" lIns="0" tIns="0" rIns="0" bIns="0" rtlCol="0" anchor="t"/>
+          <a:lstStyle/>
+          <a:p>
+            <a:pPr algn="l" indent="0" marL="0">
+              <a:buNone/>
+            </a:pPr>
+            <a:r>
               <a:rPr lang="ja-JP" altLang="en-US" sz="2200" b="1" dirty="0">
                 <a:solidFill>
                   <a:srgbClr val="D55E00"/>
@@ -6499,7 +6655,7 @@
       </p:sp>
       <p:sp>
         <p:nvSpPr>
-          <p:cNvPr id="24" name="Shape 22"/>
+          <p:cNvPr id="28" name="Shape 26"/>
           <p:cNvSpPr/>
           <p:nvPr/>
         </p:nvSpPr>
@@ -6521,7 +6677,7 @@
       </p:sp>
       <p:sp>
         <p:nvSpPr>
-          <p:cNvPr id="25" name="Text 23"/>
+          <p:cNvPr id="29" name="Text 27"/>
           <p:cNvSpPr txBox="1"/>
           <p:nvPr/>
         </p:nvSpPr>
@@ -6560,14 +6716,14 @@
       </p:sp>
       <p:sp>
         <p:nvSpPr>
-          <p:cNvPr id="26" name="Text 24"/>
+          <p:cNvPr id="30" name="Text 28"/>
           <p:cNvSpPr txBox="1"/>
           <p:nvPr/>
         </p:nvSpPr>
         <p:spPr>
           <a:xfrm>
             <a:off x="7190842" y="2063801"/>
-            <a:ext cx="4421124" cy="374904"/>
+            <a:ext cx="320040" cy="374904"/>
           </a:xfrm>
           <a:prstGeom prst="rect">
             <a:avLst/>
@@ -6583,6 +6739,45 @@
               <a:buNone/>
             </a:pPr>
             <a:r>
+              <a:rPr lang="ja-JP" altLang="en-US" sz="2200" dirty="0">
+                <a:solidFill>
+                  <a:srgbClr val="262626"/>
+                </a:solidFill>
+                <a:latin typeface="メイリオ" pitchFamily="34" charset="0"/>
+                <a:ea typeface="メイリオ" pitchFamily="34" charset="-122"/>
+                <a:cs typeface="メイリオ" pitchFamily="34" charset="-120"/>
+              </a:rPr>
+              <a:t>•</a:t>
+            </a:r>
+            <a:endParaRPr lang="ja-JP" sz="2200" dirty="0"/>
+          </a:p>
+        </p:txBody>
+      </p:sp>
+      <p:sp>
+        <p:nvSpPr>
+          <p:cNvPr id="31" name="Text 29"/>
+          <p:cNvSpPr txBox="1"/>
+          <p:nvPr/>
+        </p:nvSpPr>
+        <p:spPr>
+          <a:xfrm>
+            <a:off x="7446874" y="2063801"/>
+            <a:ext cx="4165092" cy="374904"/>
+          </a:xfrm>
+          <a:prstGeom prst="rect">
+            <a:avLst/>
+          </a:prstGeom>
+          <a:noFill/>
+          <a:ln/>
+        </p:spPr>
+        <p:txBody>
+          <a:bodyPr wrap="square" lIns="0" tIns="0" rIns="0" bIns="0" rtlCol="0" anchor="t"/>
+          <a:lstStyle/>
+          <a:p>
+            <a:pPr algn="l" indent="0" marL="0">
+              <a:buNone/>
+            </a:pPr>
+            <a:r>
               <a:rPr lang="ja-JP" altLang="en-US" sz="2200" b="1" dirty="0">
                 <a:solidFill>
                   <a:srgbClr val="262626"/>
@@ -6599,7 +6794,7 @@
       </p:sp>
       <p:sp>
         <p:nvSpPr>
-          <p:cNvPr id="27" name="Text 25"/>
+          <p:cNvPr id="32" name="Text 30"/>
           <p:cNvSpPr txBox="1"/>
           <p:nvPr/>
         </p:nvSpPr>
@@ -6649,14 +6844,14 @@
       </p:sp>
       <p:sp>
         <p:nvSpPr>
-          <p:cNvPr id="28" name="Text 26"/>
+          <p:cNvPr id="33" name="Text 31"/>
           <p:cNvSpPr txBox="1"/>
           <p:nvPr/>
         </p:nvSpPr>
         <p:spPr>
           <a:xfrm>
             <a:off x="7190842" y="2734056"/>
-            <a:ext cx="4421124" cy="374904"/>
+            <a:ext cx="320040" cy="374904"/>
           </a:xfrm>
           <a:prstGeom prst="rect">
             <a:avLst/>
@@ -6672,6 +6867,45 @@
               <a:buNone/>
             </a:pPr>
             <a:r>
+              <a:rPr lang="ja-JP" altLang="en-US" sz="2200" dirty="0">
+                <a:solidFill>
+                  <a:srgbClr val="262626"/>
+                </a:solidFill>
+                <a:latin typeface="メイリオ" pitchFamily="34" charset="0"/>
+                <a:ea typeface="メイリオ" pitchFamily="34" charset="-122"/>
+                <a:cs typeface="メイリオ" pitchFamily="34" charset="-120"/>
+              </a:rPr>
+              <a:t>•</a:t>
+            </a:r>
+            <a:endParaRPr lang="ja-JP" sz="2200" dirty="0"/>
+          </a:p>
+        </p:txBody>
+      </p:sp>
+      <p:sp>
+        <p:nvSpPr>
+          <p:cNvPr id="34" name="Text 32"/>
+          <p:cNvSpPr txBox="1"/>
+          <p:nvPr/>
+        </p:nvSpPr>
+        <p:spPr>
+          <a:xfrm>
+            <a:off x="7446874" y="2734056"/>
+            <a:ext cx="4165092" cy="374904"/>
+          </a:xfrm>
+          <a:prstGeom prst="rect">
+            <a:avLst/>
+          </a:prstGeom>
+          <a:noFill/>
+          <a:ln/>
+        </p:spPr>
+        <p:txBody>
+          <a:bodyPr wrap="square" lIns="0" tIns="0" rIns="0" bIns="0" rtlCol="0" anchor="t"/>
+          <a:lstStyle/>
+          <a:p>
+            <a:pPr algn="l" indent="0" marL="0">
+              <a:buNone/>
+            </a:pPr>
+            <a:r>
               <a:rPr lang="ja-JP" altLang="en-US" sz="2200" b="1" dirty="0">
                 <a:solidFill>
                   <a:srgbClr val="262626"/>
@@ -6680,7 +6914,7 @@
                 <a:ea typeface="メイリオ" pitchFamily="34" charset="-122"/>
                 <a:cs typeface="メイリオ" pitchFamily="34" charset="-120"/>
               </a:rPr>
-              <a:t>腎機能は eGFR ではなく CrCl</a:t>
+              <a:t>腎機能は eGFR ではなく</a:t>
             </a:r>
             <a:endParaRPr lang="ja-JP" sz="2200" dirty="0"/>
           </a:p>
@@ -6688,7 +6922,7 @@
       </p:sp>
       <p:sp>
         <p:nvSpPr>
-          <p:cNvPr id="29" name="Text 27"/>
+          <p:cNvPr id="35" name="Text 33"/>
           <p:cNvSpPr txBox="1"/>
           <p:nvPr/>
         </p:nvSpPr>
@@ -6711,6 +6945,17 @@
               <a:buNone/>
             </a:pPr>
             <a:r>
+              <a:rPr lang="ja-JP" altLang="en-US" sz="2200" b="1" dirty="0">
+                <a:solidFill>
+                  <a:srgbClr val="262626"/>
+                </a:solidFill>
+                <a:latin typeface="メイリオ" pitchFamily="34" charset="0"/>
+                <a:ea typeface="メイリオ" pitchFamily="34" charset="-122"/>
+                <a:cs typeface="メイリオ" pitchFamily="34" charset="-120"/>
+              </a:rPr>
+              <a:t>CrCl</a:t>
+            </a:r>
+            <a:r>
               <a:rPr lang="ja-JP" altLang="en-US" sz="2200" dirty="0">
                 <a:solidFill>
                   <a:srgbClr val="262626"/>
@@ -6727,14 +6972,14 @@
       </p:sp>
       <p:sp>
         <p:nvSpPr>
-          <p:cNvPr id="30" name="Text 28"/>
+          <p:cNvPr id="36" name="Text 34"/>
           <p:cNvSpPr txBox="1"/>
           <p:nvPr/>
         </p:nvSpPr>
         <p:spPr>
           <a:xfrm>
             <a:off x="7190842" y="3404311"/>
-            <a:ext cx="4421124" cy="374904"/>
+            <a:ext cx="320040" cy="374904"/>
           </a:xfrm>
           <a:prstGeom prst="rect">
             <a:avLst/>
@@ -6750,6 +6995,45 @@
               <a:buNone/>
             </a:pPr>
             <a:r>
+              <a:rPr lang="ja-JP" altLang="en-US" sz="2200" dirty="0">
+                <a:solidFill>
+                  <a:srgbClr val="262626"/>
+                </a:solidFill>
+                <a:latin typeface="メイリオ" pitchFamily="34" charset="0"/>
+                <a:ea typeface="メイリオ" pitchFamily="34" charset="-122"/>
+                <a:cs typeface="メイリオ" pitchFamily="34" charset="-120"/>
+              </a:rPr>
+              <a:t>•</a:t>
+            </a:r>
+            <a:endParaRPr lang="ja-JP" sz="2200" dirty="0"/>
+          </a:p>
+        </p:txBody>
+      </p:sp>
+      <p:sp>
+        <p:nvSpPr>
+          <p:cNvPr id="37" name="Text 35"/>
+          <p:cNvSpPr txBox="1"/>
+          <p:nvPr/>
+        </p:nvSpPr>
+        <p:spPr>
+          <a:xfrm>
+            <a:off x="7446874" y="3404311"/>
+            <a:ext cx="4165092" cy="374904"/>
+          </a:xfrm>
+          <a:prstGeom prst="rect">
+            <a:avLst/>
+          </a:prstGeom>
+          <a:noFill/>
+          <a:ln/>
+        </p:spPr>
+        <p:txBody>
+          <a:bodyPr wrap="square" lIns="0" tIns="0" rIns="0" bIns="0" rtlCol="0" anchor="t"/>
+          <a:lstStyle/>
+          <a:p>
+            <a:pPr algn="l" indent="0" marL="0">
+              <a:buNone/>
+            </a:pPr>
+            <a:r>
               <a:rPr lang="ja-JP" altLang="en-US" sz="2200" b="1" dirty="0">
                 <a:solidFill>
                   <a:srgbClr val="262626"/>
@@ -6766,7 +7050,7 @@
       </p:sp>
       <p:sp>
         <p:nvSpPr>
-          <p:cNvPr id="31" name="Text 29"/>
+          <p:cNvPr id="38" name="Text 36"/>
           <p:cNvSpPr txBox="1"/>
           <p:nvPr/>
         </p:nvSpPr>
@@ -6797,7 +7081,7 @@
                 <a:ea typeface="メイリオ" pitchFamily="34" charset="-122"/>
                 <a:cs typeface="メイリオ" pitchFamily="34" charset="-120"/>
               </a:rPr>
-              <a:t>（→ S6）</a:t>
+              <a:t>（→ 区域麻酔①）</a:t>
             </a:r>
             <a:endParaRPr lang="ja-JP" sz="2200" dirty="0"/>
           </a:p>
@@ -6805,14 +7089,14 @@
       </p:sp>
       <p:sp>
         <p:nvSpPr>
-          <p:cNvPr id="32" name="Text 30"/>
+          <p:cNvPr id="39" name="Text 37"/>
           <p:cNvSpPr txBox="1"/>
           <p:nvPr/>
         </p:nvSpPr>
         <p:spPr>
           <a:xfrm>
             <a:off x="7190842" y="4075481"/>
-            <a:ext cx="4421124" cy="374904"/>
+            <a:ext cx="320040" cy="374904"/>
           </a:xfrm>
           <a:prstGeom prst="rect">
             <a:avLst/>
@@ -6828,6 +7112,45 @@
               <a:buNone/>
             </a:pPr>
             <a:r>
+              <a:rPr lang="ja-JP" altLang="en-US" sz="2200" dirty="0">
+                <a:solidFill>
+                  <a:srgbClr val="262626"/>
+                </a:solidFill>
+                <a:latin typeface="メイリオ" pitchFamily="34" charset="0"/>
+                <a:ea typeface="メイリオ" pitchFamily="34" charset="-122"/>
+                <a:cs typeface="メイリオ" pitchFamily="34" charset="-120"/>
+              </a:rPr>
+              <a:t>•</a:t>
+            </a:r>
+            <a:endParaRPr lang="ja-JP" sz="2200" dirty="0"/>
+          </a:p>
+        </p:txBody>
+      </p:sp>
+      <p:sp>
+        <p:nvSpPr>
+          <p:cNvPr id="40" name="Text 38"/>
+          <p:cNvSpPr txBox="1"/>
+          <p:nvPr/>
+        </p:nvSpPr>
+        <p:spPr>
+          <a:xfrm>
+            <a:off x="7446874" y="4075481"/>
+            <a:ext cx="4165092" cy="374904"/>
+          </a:xfrm>
+          <a:prstGeom prst="rect">
+            <a:avLst/>
+          </a:prstGeom>
+          <a:noFill/>
+          <a:ln/>
+        </p:spPr>
+        <p:txBody>
+          <a:bodyPr wrap="square" lIns="0" tIns="0" rIns="0" bIns="0" rtlCol="0" anchor="t"/>
+          <a:lstStyle/>
+          <a:p>
+            <a:pPr algn="l" indent="0" marL="0">
+              <a:buNone/>
+            </a:pPr>
+            <a:r>
               <a:rPr lang="ja-JP" altLang="en-US" sz="2200" b="1" dirty="0">
                 <a:solidFill>
                   <a:srgbClr val="262626"/>
@@ -6844,7 +7167,7 @@
       </p:sp>
       <p:sp>
         <p:nvSpPr>
-          <p:cNvPr id="33" name="Text 31"/>
+          <p:cNvPr id="41" name="Text 39"/>
           <p:cNvSpPr txBox="1"/>
           <p:nvPr/>
         </p:nvSpPr>
@@ -7111,7 +7434,7 @@
                 <a:ea typeface="メイリオ" pitchFamily="34" charset="-122"/>
                 <a:cs typeface="メイリオ" pitchFamily="34" charset="-120"/>
               </a:rPr>
-              <a:t>抗血小板</a:t>
+              <a:t>抗血小</a:t>
             </a:r>
             <a:endParaRPr lang="ja-JP" sz="1050" dirty="0"/>
           </a:p>
@@ -7128,7 +7451,7 @@
                 <a:ea typeface="メイリオ" pitchFamily="34" charset="-122"/>
                 <a:cs typeface="メイリオ" pitchFamily="34" charset="-120"/>
               </a:rPr>
-              <a:t>薬</a:t>
+              <a:t>板薬</a:t>
             </a:r>
             <a:endParaRPr lang="ja-JP" sz="1050" dirty="0"/>
           </a:p>
@@ -8863,7 +9186,7 @@
                 <a:ea typeface="メイリオ" pitchFamily="34" charset="-122"/>
                 <a:cs typeface="メイリオ" pitchFamily="34" charset="-120"/>
               </a:rPr>
-              <a:t>抗血小板</a:t>
+              <a:t>抗血小</a:t>
             </a:r>
             <a:endParaRPr lang="ja-JP" sz="1050" dirty="0"/>
           </a:p>
@@ -8880,7 +9203,7 @@
                 <a:ea typeface="メイリオ" pitchFamily="34" charset="-122"/>
                 <a:cs typeface="メイリオ" pitchFamily="34" charset="-120"/>
               </a:rPr>
-              <a:t>薬</a:t>
+              <a:t>板薬</a:t>
             </a:r>
             <a:endParaRPr lang="ja-JP" sz="1050" dirty="0"/>
           </a:p>
@@ -10591,7 +10914,7 @@
                 <a:ea typeface="メイリオ" pitchFamily="34" charset="-122"/>
                 <a:cs typeface="メイリオ" pitchFamily="34" charset="-120"/>
               </a:rPr>
-              <a:t>抗血小板</a:t>
+              <a:t>抗血小</a:t>
             </a:r>
             <a:endParaRPr lang="ja-JP" sz="1050" dirty="0"/>
           </a:p>
@@ -10608,7 +10931,7 @@
                 <a:ea typeface="メイリオ" pitchFamily="34" charset="-122"/>
                 <a:cs typeface="メイリオ" pitchFamily="34" charset="-120"/>
               </a:rPr>
-              <a:t>薬</a:t>
+              <a:t>板薬</a:t>
             </a:r>
             <a:endParaRPr lang="ja-JP" sz="1050" dirty="0"/>
           </a:p>
@@ -10835,9 +11158,9 @@
             <a:tbl>
               <a:tblPr/>
               <a:tblGrid>
-                <a:gridCol w="2350008"/>
-                <a:gridCol w="6693408"/>
-                <a:gridCol w="2112264"/>
+                <a:gridCol w="1792224"/>
+                <a:gridCol w="6254496"/>
+                <a:gridCol w="3108960"/>
               </a:tblGrid>
               <a:tr h="749808">
                 <a:tc>
@@ -11308,7 +11631,7 @@
                   </a:tcPr>
                 </a:tc>
               </a:tr>
-              <a:tr h="749808">
+              <a:tr h="1088136">
                 <a:tc>
                   <a:txBody>
                     <a:bodyPr/>
@@ -11329,7 +11652,31 @@
                           <a:ea typeface="メイリオ" pitchFamily="34" charset="-122"/>
                           <a:cs typeface="メイリオ" pitchFamily="34" charset="-120"/>
                         </a:rPr>
-                        <a:t>未分画ヘパリン</a:t>
+                        <a:t>未分画</a:t>
+                      </a:r>
+                      <a:endParaRPr lang="en-US" sz="2200" dirty="0">
+                        <a:latin typeface="メイリオ" charset="0"/>
+                        <a:ea typeface="メイリオ" charset="0"/>
+                        <a:cs typeface="メイリオ" charset="0"/>
+                      </a:endParaRPr>
+                    </a:p>
+                    <a:p>
+                      <a:pPr algn="l" indent="0" marL="0">
+                        <a:lnSpc>
+                          <a:spcPts val="2640"/>
+                        </a:lnSpc>
+                        <a:buNone/>
+                      </a:pPr>
+                      <a:r>
+                        <a:rPr lang="ja-JP" altLang="en-US" sz="2200" b="1" dirty="0">
+                          <a:solidFill>
+                            <a:srgbClr val="262626"/>
+                          </a:solidFill>
+                          <a:latin typeface="メイリオ" pitchFamily="34" charset="0"/>
+                          <a:ea typeface="メイリオ" pitchFamily="34" charset="-122"/>
+                          <a:cs typeface="メイリオ" pitchFamily="34" charset="-120"/>
+                        </a:rPr>
+                        <a:t>ヘパリン</a:t>
                       </a:r>
                       <a:endParaRPr lang="en-US" sz="2200" dirty="0">
                         <a:latin typeface="メイリオ" charset="0"/>
@@ -11397,7 +11744,31 @@
                           <a:ea typeface="メイリオ" pitchFamily="34" charset="-122"/>
                           <a:cs typeface="メイリオ" pitchFamily="34" charset="-120"/>
                         </a:rPr>
-                        <a:t>皮下 低用量 4〜6 時間、高用量 12〜24 時間。</a:t>
+                        <a:t>皮下 低用量 4〜6 時間、</a:t>
+                      </a:r>
+                      <a:endParaRPr lang="en-US" sz="2200" dirty="0">
+                        <a:latin typeface="メイリオ" charset="0"/>
+                        <a:ea typeface="メイリオ" charset="0"/>
+                        <a:cs typeface="メイリオ" charset="0"/>
+                      </a:endParaRPr>
+                    </a:p>
+                    <a:p>
+                      <a:pPr algn="l" indent="0" marL="0">
+                        <a:lnSpc>
+                          <a:spcPts val="2640"/>
+                        </a:lnSpc>
+                        <a:buNone/>
+                      </a:pPr>
+                      <a:r>
+                        <a:rPr lang="ja-JP" altLang="en-US" sz="2200" dirty="0">
+                          <a:solidFill>
+                            <a:srgbClr val="262626"/>
+                          </a:solidFill>
+                          <a:latin typeface="メイリオ" pitchFamily="34" charset="0"/>
+                          <a:ea typeface="メイリオ" pitchFamily="34" charset="-122"/>
+                          <a:cs typeface="メイリオ" pitchFamily="34" charset="-120"/>
+                        </a:rPr>
+                        <a:t>高用量 12〜24 時間。</a:t>
                       </a:r>
                       <a:endParaRPr lang="en-US" sz="2200" dirty="0">
                         <a:latin typeface="メイリオ" charset="0"/>
@@ -11538,7 +11909,7 @@
                   </a:tcPr>
                 </a:tc>
               </a:tr>
-              <a:tr h="1417320">
+              <a:tr h="1088136">
                 <a:tc>
                   <a:txBody>
                     <a:bodyPr/>
@@ -11651,7 +12022,7 @@
                           <a:ea typeface="メイリオ" pitchFamily="34" charset="-122"/>
                           <a:cs typeface="メイリオ" pitchFamily="34" charset="-120"/>
                         </a:rPr>
-                        <a:t>クロピドグレル 5〜7 日、チカグレロル 5 日、</a:t>
+                        <a:t>クロピドグレル 5〜7 日、</a:t>
                       </a:r>
                       <a:endParaRPr lang="en-US" sz="2200" dirty="0">
                         <a:latin typeface="メイリオ" charset="0"/>
@@ -11675,7 +12046,7 @@
                           <a:ea typeface="メイリオ" pitchFamily="34" charset="-122"/>
                           <a:cs typeface="メイリオ" pitchFamily="34" charset="-120"/>
                         </a:rPr>
-                        <a:t>プラスグレル 7〜10 日</a:t>
+                        <a:t>チカグレロル 5 日、プラスグレル 7〜10 日</a:t>
                       </a:r>
                       <a:endParaRPr lang="en-US" sz="2200" dirty="0">
                         <a:latin typeface="メイリオ" charset="0"/>
@@ -11743,7 +12114,7 @@
                           <a:ea typeface="メイリオ" pitchFamily="34" charset="-122"/>
                           <a:cs typeface="メイリオ" pitchFamily="34" charset="-120"/>
                         </a:rPr>
-                        <a:t>負荷なし：</a:t>
+                        <a:t>負荷なし：すぐ、</a:t>
                       </a:r>
                       <a:endParaRPr lang="en-US" sz="2200" dirty="0">
                         <a:latin typeface="メイリオ" charset="0"/>
@@ -11767,55 +12138,7 @@
                           <a:ea typeface="メイリオ" pitchFamily="34" charset="-122"/>
                           <a:cs typeface="メイリオ" pitchFamily="34" charset="-120"/>
                         </a:rPr>
-                        <a:t>すぐ、</a:t>
-                      </a:r>
-                      <a:endParaRPr lang="en-US" sz="2200" dirty="0">
-                        <a:latin typeface="メイリオ" charset="0"/>
-                        <a:ea typeface="メイリオ" charset="0"/>
-                        <a:cs typeface="メイリオ" charset="0"/>
-                      </a:endParaRPr>
-                    </a:p>
-                    <a:p>
-                      <a:pPr algn="l" indent="0" marL="0">
-                        <a:lnSpc>
-                          <a:spcPts val="2640"/>
-                        </a:lnSpc>
-                        <a:buNone/>
-                      </a:pPr>
-                      <a:r>
-                        <a:rPr lang="ja-JP" altLang="en-US" sz="2200" dirty="0">
-                          <a:solidFill>
-                            <a:srgbClr val="262626"/>
-                          </a:solidFill>
-                          <a:latin typeface="メイリオ" pitchFamily="34" charset="0"/>
-                          <a:ea typeface="メイリオ" pitchFamily="34" charset="-122"/>
-                          <a:cs typeface="メイリオ" pitchFamily="34" charset="-120"/>
-                        </a:rPr>
-                        <a:t>負荷あり：</a:t>
-                      </a:r>
-                      <a:endParaRPr lang="en-US" sz="2200" dirty="0">
-                        <a:latin typeface="メイリオ" charset="0"/>
-                        <a:ea typeface="メイリオ" charset="0"/>
-                        <a:cs typeface="メイリオ" charset="0"/>
-                      </a:endParaRPr>
-                    </a:p>
-                    <a:p>
-                      <a:pPr algn="l" indent="0" marL="0">
-                        <a:lnSpc>
-                          <a:spcPts val="2640"/>
-                        </a:lnSpc>
-                        <a:buNone/>
-                      </a:pPr>
-                      <a:r>
-                        <a:rPr lang="ja-JP" altLang="en-US" sz="2200" dirty="0">
-                          <a:solidFill>
-                            <a:srgbClr val="262626"/>
-                          </a:solidFill>
-                          <a:latin typeface="メイリオ" pitchFamily="34" charset="0"/>
-                          <a:ea typeface="メイリオ" pitchFamily="34" charset="-122"/>
-                          <a:cs typeface="メイリオ" pitchFamily="34" charset="-120"/>
-                        </a:rPr>
-                        <a:t>6 時間後</a:t>
+                        <a:t>負荷あり：6 時間後</a:t>
                       </a:r>
                       <a:endParaRPr lang="en-US" sz="2200" dirty="0">
                         <a:latin typeface="メイリオ" charset="0"/>
@@ -11876,7 +12199,7 @@
         </p:nvSpPr>
         <p:spPr>
           <a:xfrm>
-            <a:off x="502920" y="5303520"/>
+            <a:off x="502920" y="5312664"/>
             <a:ext cx="11183112" cy="457200"/>
           </a:xfrm>
           <a:prstGeom prst="rect">
@@ -12137,7 +12460,7 @@
                 <a:ea typeface="メイリオ" pitchFamily="34" charset="-122"/>
                 <a:cs typeface="メイリオ" pitchFamily="34" charset="-120"/>
               </a:rPr>
-              <a:t>抗血小板</a:t>
+              <a:t>抗血小</a:t>
             </a:r>
             <a:endParaRPr lang="ja-JP" sz="1050" dirty="0"/>
           </a:p>
@@ -12154,7 +12477,7 @@
                 <a:ea typeface="メイリオ" pitchFamily="34" charset="-122"/>
                 <a:cs typeface="メイリオ" pitchFamily="34" charset="-120"/>
               </a:rPr>
-              <a:t>薬</a:t>
+              <a:t>板薬</a:t>
             </a:r>
             <a:endParaRPr lang="ja-JP" sz="1050" dirty="0"/>
           </a:p>
@@ -13726,7 +14049,7 @@
                 <a:ea typeface="メイリオ" pitchFamily="34" charset="-122"/>
                 <a:cs typeface="メイリオ" pitchFamily="34" charset="-120"/>
               </a:rPr>
-              <a:t>抗血小板</a:t>
+              <a:t>抗血小</a:t>
             </a:r>
             <a:endParaRPr lang="ja-JP" sz="1050" dirty="0"/>
           </a:p>
@@ -13743,7 +14066,7 @@
                 <a:ea typeface="メイリオ" pitchFamily="34" charset="-122"/>
                 <a:cs typeface="メイリオ" pitchFamily="34" charset="-120"/>
               </a:rPr>
-              <a:t>薬</a:t>
+              <a:t>板薬</a:t>
             </a:r>
             <a:endParaRPr lang="ja-JP" sz="1050" dirty="0"/>
           </a:p>
@@ -13956,11 +14279,11 @@
         <p:spPr>
           <a:xfrm>
             <a:off x="502920" y="1664208"/>
-            <a:ext cx="11183112" cy="3538728"/>
+            <a:ext cx="11183112" cy="3547872"/>
           </a:xfrm>
           <a:prstGeom prst="roundRect">
             <a:avLst>
-              <a:gd name="adj" fmla="val 2067"/>
+              <a:gd name="adj" fmla="val 2062"/>
             </a:avLst>
           </a:prstGeom>
           <a:solidFill>
@@ -14038,7 +14361,7 @@
         </p:nvSpPr>
         <p:spPr>
           <a:xfrm>
-            <a:off x="896112" y="2127809"/>
+            <a:off x="896112" y="2091233"/>
             <a:ext cx="10707624" cy="374904"/>
           </a:xfrm>
           <a:prstGeom prst="rect">
@@ -14063,7 +14386,7 @@
                 <a:ea typeface="メイリオ" pitchFamily="34" charset="-122"/>
                 <a:cs typeface="メイリオ" pitchFamily="34" charset="-120"/>
               </a:rPr>
-              <a:t>手術 4 日前の夜（◯/◯ 20 時）。脊髄くも膜下麻酔の予定のため</a:t>
+              <a:t>手術 4 日前の夜（○/○ 20 時）。脊髄くも膜下麻酔の予定のため</a:t>
             </a:r>
             <a:endParaRPr lang="ja-JP" sz="2200" dirty="0"/>
           </a:p>
@@ -14077,7 +14400,7 @@
         </p:nvSpPr>
         <p:spPr>
           <a:xfrm>
-            <a:off x="896112" y="2462479"/>
+            <a:off x="896112" y="2425903"/>
             <a:ext cx="10707624" cy="374904"/>
           </a:xfrm>
           <a:prstGeom prst="rect">
@@ -14127,7 +14450,7 @@
         </p:nvSpPr>
         <p:spPr>
           <a:xfrm>
-            <a:off x="585216" y="2852928"/>
+            <a:off x="585216" y="2816352"/>
             <a:ext cx="11018520" cy="374904"/>
           </a:xfrm>
           <a:prstGeom prst="rect">
@@ -14163,7 +14486,7 @@
                 <a:ea typeface="メイリオ" pitchFamily="34" charset="-122"/>
                 <a:cs typeface="メイリオ" pitchFamily="34" charset="-120"/>
               </a:rPr>
-              <a:t>術後 2 日目の夜、止血を確認してから。処方医（◯◯内科）に連絡済み</a:t>
+              <a:t>術後 2 日目の夜、止血を確認してから。処方医（○○内科）に連絡済み</a:t>
             </a:r>
             <a:endParaRPr lang="ja-JP" sz="2200" dirty="0"/>
           </a:p>
@@ -14177,7 +14500,7 @@
         </p:nvSpPr>
         <p:spPr>
           <a:xfrm>
-            <a:off x="585216" y="3266237"/>
+            <a:off x="585216" y="3261665"/>
             <a:ext cx="11018520" cy="0"/>
           </a:xfrm>
           <a:prstGeom prst="line">
@@ -14200,7 +14523,7 @@
         </p:nvSpPr>
         <p:spPr>
           <a:xfrm>
-            <a:off x="585216" y="3343961"/>
+            <a:off x="585216" y="3353105"/>
             <a:ext cx="11018520" cy="374904"/>
           </a:xfrm>
           <a:prstGeom prst="rect">
@@ -14261,7 +14584,7 @@
         </p:nvSpPr>
         <p:spPr>
           <a:xfrm>
-            <a:off x="585216" y="3733495"/>
+            <a:off x="585216" y="3742639"/>
             <a:ext cx="11018520" cy="374904"/>
           </a:xfrm>
           <a:prstGeom prst="rect">
@@ -14297,7 +14620,7 @@
                 <a:ea typeface="メイリオ" pitchFamily="34" charset="-122"/>
                 <a:cs typeface="メイリオ" pitchFamily="34" charset="-120"/>
               </a:rPr>
-              <a:t>：PCI 施行医（循環器 ◯◯医師）と相談し、</a:t>
+              <a:t>：PCI 施行医（循環器 ○○医師）と相談し、</a:t>
             </a:r>
             <a:endParaRPr lang="ja-JP" sz="2200" dirty="0"/>
           </a:p>
@@ -14311,7 +14634,7 @@
         </p:nvSpPr>
         <p:spPr>
           <a:xfrm>
-            <a:off x="896112" y="4105656"/>
+            <a:off x="896112" y="4078224"/>
             <a:ext cx="10707624" cy="374904"/>
           </a:xfrm>
           <a:prstGeom prst="rect">
@@ -14336,7 +14659,7 @@
                 <a:ea typeface="メイリオ" pitchFamily="34" charset="-122"/>
                 <a:cs typeface="メイリオ" pitchFamily="34" charset="-120"/>
               </a:rPr>
-              <a:t>最終内服は手術 7 日前の朝（◯/◯ 8 時）。</a:t>
+              <a:t>最終内服は手術 7 日前の朝（○/○ 8 時）。</a:t>
             </a:r>
             <a:endParaRPr lang="ja-JP" sz="2200" dirty="0"/>
           </a:p>
@@ -14350,7 +14673,7 @@
         </p:nvSpPr>
         <p:spPr>
           <a:xfrm>
-            <a:off x="896112" y="4441241"/>
+            <a:off x="896112" y="4413809"/>
             <a:ext cx="10707624" cy="374904"/>
           </a:xfrm>
           <a:prstGeom prst="rect">
@@ -14411,7 +14734,7 @@
         </p:nvSpPr>
         <p:spPr>
           <a:xfrm>
-            <a:off x="896112" y="4775911"/>
+            <a:off x="896112" y="4748479"/>
             <a:ext cx="10707624" cy="374904"/>
           </a:xfrm>
           <a:prstGeom prst="rect">
@@ -14450,7 +14773,7 @@
         </p:nvSpPr>
         <p:spPr>
           <a:xfrm>
-            <a:off x="502920" y="5426964"/>
+            <a:off x="502920" y="5431536"/>
             <a:ext cx="11183112" cy="457200"/>
           </a:xfrm>
           <a:prstGeom prst="rect">
@@ -14475,7 +14798,7 @@
                 <a:ea typeface="メイリオ" pitchFamily="34" charset="-122"/>
                 <a:cs typeface="メイリオ" pitchFamily="34" charset="-120"/>
               </a:rPr>
-              <a:t>『◯日前から中止』ではなく、</a:t>
+              <a:t>『○日前から中止』ではなく、</a:t>
             </a:r>
             <a:r>
               <a:rPr lang="ja-JP" altLang="en-US" sz="2400" b="1" dirty="0">

</xml_diff>